<commit_message>
Restructure coapps, add BookApps and CLI tools
Reorganize project modules and add book-related utilities and CLI flows. Changes include: moved/renamed modules (scan and tsvgen relocated under coapps), updated imports accordingly; added new BookApps (BookJAN, ISBN, RakutenAPI) for JAN/ISBN parsing and Rakuten API lookup; added coapps/settings for loading ISBN range XML; added coapps/create and top-level crud.py and app.py to provide inquirer-based CLI flows (book creation, CoApps launcher); implemented TSVCodeGenerator.tsv_to_s_tsv helper; added s_tsv_code columns to several ORM models (Record, Issuer, Book, BookGroup, Shelf); removed obsolete coapps/database/books.py; moved README/TSV docs into READUS; added small utility add.py and database/persistent changes (binary DB and pptx updated). Import paths were adjusted throughout to match the new layout.
</commit_message>
<xml_diff>
--- a/処理フロー.pptx
+++ b/処理フロー.pptx
@@ -10,8 +10,7 @@
     <p:sldId id="258" r:id="rId4"/>
     <p:sldId id="260" r:id="rId5"/>
     <p:sldId id="261" r:id="rId6"/>
-    <p:sldId id="262" r:id="rId7"/>
-    <p:sldId id="259" r:id="rId8"/>
+    <p:sldId id="259" r:id="rId7"/>
   </p:sldIdLst>
   <p:sldSz cx="12192000" cy="6858000"/>
   <p:notesSz cx="6858000" cy="9144000"/>
@@ -110,6 +109,11 @@
       </a:defRPr>
     </a:lvl9pPr>
   </p:defaultTextStyle>
+  <p:extLst>
+    <p:ext uri="{EFAFB233-063F-42B5-8137-9DF3F51BA10A}">
+      <p15:sldGuideLst xmlns:p15="http://schemas.microsoft.com/office/powerpoint/2012/main"/>
+    </p:ext>
+  </p:extLst>
 </p:presentation>
 </file>
 
@@ -15937,7 +15941,7 @@
           <a:p>
             <a:fld id="{4F83154F-4C5D-7D4C-8443-BC5E486C2899}" type="datetimeFigureOut">
               <a:rPr kumimoji="1" lang="ja-JP" altLang="en-US" smtClean="0"/>
-              <a:t>2026/5/31</a:t>
+              <a:t>2026/6/5</a:t>
             </a:fld>
             <a:endParaRPr kumimoji="1" lang="ja-JP" altLang="en-US"/>
           </a:p>
@@ -16282,7 +16286,7 @@
           <a:p>
             <a:fld id="{4F83154F-4C5D-7D4C-8443-BC5E486C2899}" type="datetimeFigureOut">
               <a:rPr kumimoji="1" lang="ja-JP" altLang="en-US" smtClean="0"/>
-              <a:t>2026/5/31</a:t>
+              <a:t>2026/6/5</a:t>
             </a:fld>
             <a:endParaRPr kumimoji="1" lang="ja-JP" altLang="en-US"/>
           </a:p>
@@ -16683,7 +16687,7 @@
           <a:p>
             <a:fld id="{4F83154F-4C5D-7D4C-8443-BC5E486C2899}" type="datetimeFigureOut">
               <a:rPr kumimoji="1" lang="ja-JP" altLang="en-US" smtClean="0"/>
-              <a:t>2026/5/31</a:t>
+              <a:t>2026/6/5</a:t>
             </a:fld>
             <a:endParaRPr kumimoji="1" lang="ja-JP" altLang="en-US"/>
           </a:p>
@@ -17019,7 +17023,7 @@
           <a:p>
             <a:fld id="{4F83154F-4C5D-7D4C-8443-BC5E486C2899}" type="datetimeFigureOut">
               <a:rPr kumimoji="1" lang="ja-JP" altLang="en-US" smtClean="0"/>
-              <a:t>2026/5/31</a:t>
+              <a:t>2026/6/5</a:t>
             </a:fld>
             <a:endParaRPr kumimoji="1" lang="ja-JP" altLang="en-US"/>
           </a:p>
@@ -17339,7 +17343,7 @@
           <a:p>
             <a:fld id="{4F83154F-4C5D-7D4C-8443-BC5E486C2899}" type="datetimeFigureOut">
               <a:rPr kumimoji="1" lang="ja-JP" altLang="en-US" smtClean="0"/>
-              <a:t>2026/5/31</a:t>
+              <a:t>2026/6/5</a:t>
             </a:fld>
             <a:endParaRPr kumimoji="1" lang="ja-JP" altLang="en-US"/>
           </a:p>
@@ -17735,7 +17739,7 @@
           <a:p>
             <a:fld id="{4F83154F-4C5D-7D4C-8443-BC5E486C2899}" type="datetimeFigureOut">
               <a:rPr kumimoji="1" lang="ja-JP" altLang="en-US" smtClean="0"/>
-              <a:t>2026/5/31</a:t>
+              <a:t>2026/6/5</a:t>
             </a:fld>
             <a:endParaRPr kumimoji="1" lang="ja-JP" altLang="en-US"/>
           </a:p>
@@ -18024,7 +18028,7 @@
           <a:p>
             <a:fld id="{4F83154F-4C5D-7D4C-8443-BC5E486C2899}" type="datetimeFigureOut">
               <a:rPr kumimoji="1" lang="ja-JP" altLang="en-US" smtClean="0"/>
-              <a:t>2026/5/31</a:t>
+              <a:t>2026/6/5</a:t>
             </a:fld>
             <a:endParaRPr kumimoji="1" lang="ja-JP" altLang="en-US"/>
           </a:p>
@@ -18318,7 +18322,7 @@
           <a:p>
             <a:fld id="{4F83154F-4C5D-7D4C-8443-BC5E486C2899}" type="datetimeFigureOut">
               <a:rPr kumimoji="1" lang="ja-JP" altLang="en-US" smtClean="0"/>
-              <a:t>2026/5/31</a:t>
+              <a:t>2026/6/5</a:t>
             </a:fld>
             <a:endParaRPr kumimoji="1" lang="ja-JP" altLang="en-US"/>
           </a:p>
@@ -18612,7 +18616,7 @@
           <a:p>
             <a:fld id="{4F83154F-4C5D-7D4C-8443-BC5E486C2899}" type="datetimeFigureOut">
               <a:rPr kumimoji="1" lang="ja-JP" altLang="en-US" smtClean="0"/>
-              <a:t>2026/5/31</a:t>
+              <a:t>2026/6/5</a:t>
             </a:fld>
             <a:endParaRPr kumimoji="1" lang="ja-JP" altLang="en-US"/>
           </a:p>
@@ -18948,7 +18952,7 @@
           <a:p>
             <a:fld id="{4F83154F-4C5D-7D4C-8443-BC5E486C2899}" type="datetimeFigureOut">
               <a:rPr kumimoji="1" lang="ja-JP" altLang="en-US" smtClean="0"/>
-              <a:t>2026/5/31</a:t>
+              <a:t>2026/6/5</a:t>
             </a:fld>
             <a:endParaRPr kumimoji="1" lang="ja-JP" altLang="en-US"/>
           </a:p>
@@ -19335,7 +19339,7 @@
           <a:p>
             <a:fld id="{4F83154F-4C5D-7D4C-8443-BC5E486C2899}" type="datetimeFigureOut">
               <a:rPr kumimoji="1" lang="ja-JP" altLang="en-US" smtClean="0"/>
-              <a:t>2026/5/31</a:t>
+              <a:t>2026/6/5</a:t>
             </a:fld>
             <a:endParaRPr kumimoji="1" lang="ja-JP" altLang="en-US"/>
           </a:p>
@@ -19856,7 +19860,7 @@
           <a:p>
             <a:fld id="{4F83154F-4C5D-7D4C-8443-BC5E486C2899}" type="datetimeFigureOut">
               <a:rPr kumimoji="1" lang="ja-JP" altLang="en-US" smtClean="0"/>
-              <a:t>2026/5/31</a:t>
+              <a:t>2026/6/5</a:t>
             </a:fld>
             <a:endParaRPr kumimoji="1" lang="ja-JP" altLang="en-US"/>
           </a:p>
@@ -20068,7 +20072,7 @@
           <a:p>
             <a:fld id="{4F83154F-4C5D-7D4C-8443-BC5E486C2899}" type="datetimeFigureOut">
               <a:rPr kumimoji="1" lang="ja-JP" altLang="en-US" smtClean="0"/>
-              <a:t>2026/5/31</a:t>
+              <a:t>2026/6/5</a:t>
             </a:fld>
             <a:endParaRPr kumimoji="1" lang="ja-JP" altLang="en-US"/>
           </a:p>
@@ -20245,7 +20249,7 @@
           <a:p>
             <a:fld id="{4F83154F-4C5D-7D4C-8443-BC5E486C2899}" type="datetimeFigureOut">
               <a:rPr kumimoji="1" lang="ja-JP" altLang="en-US" smtClean="0"/>
-              <a:t>2026/5/31</a:t>
+              <a:t>2026/6/5</a:t>
             </a:fld>
             <a:endParaRPr kumimoji="1" lang="ja-JP" altLang="en-US"/>
           </a:p>
@@ -20610,7 +20614,7 @@
           <a:p>
             <a:fld id="{4F83154F-4C5D-7D4C-8443-BC5E486C2899}" type="datetimeFigureOut">
               <a:rPr kumimoji="1" lang="ja-JP" altLang="en-US" smtClean="0"/>
-              <a:t>2026/5/31</a:t>
+              <a:t>2026/6/5</a:t>
             </a:fld>
             <a:endParaRPr kumimoji="1" lang="ja-JP" altLang="en-US"/>
           </a:p>
@@ -20955,7 +20959,7 @@
           <a:p>
             <a:fld id="{4F83154F-4C5D-7D4C-8443-BC5E486C2899}" type="datetimeFigureOut">
               <a:rPr kumimoji="1" lang="ja-JP" altLang="en-US" smtClean="0"/>
-              <a:t>2026/5/31</a:t>
+              <a:t>2026/6/5</a:t>
             </a:fld>
             <a:endParaRPr kumimoji="1" lang="ja-JP" altLang="en-US"/>
           </a:p>
@@ -23279,7 +23283,7 @@
           <a:p>
             <a:fld id="{4F83154F-4C5D-7D4C-8443-BC5E486C2899}" type="datetimeFigureOut">
               <a:rPr kumimoji="1" lang="ja-JP" altLang="en-US" smtClean="0"/>
-              <a:t>2026/5/31</a:t>
+              <a:t>2026/6/5</a:t>
             </a:fld>
             <a:endParaRPr kumimoji="1" lang="ja-JP" altLang="en-US"/>
           </a:p>
@@ -23867,33 +23871,6 @@
           <a:bodyPr/>
           <a:lstStyle/>
           <a:p>
-            <a:r>
-              <a:rPr kumimoji="1" lang="ja-JP" altLang="en-US"/>
-              <a:t>かえつ有明高等学校</a:t>
-            </a:r>
-            <a:r>
-              <a:rPr kumimoji="1" lang="en-US" altLang="ja-JP" dirty="0"/>
-              <a:t> </a:t>
-            </a:r>
-            <a:r>
-              <a:rPr kumimoji="1" lang="ja-JP" altLang="en-US"/>
-              <a:t>第一学年</a:t>
-            </a:r>
-            <a:r>
-              <a:rPr kumimoji="1" lang="en-US" altLang="ja-JP" dirty="0"/>
-              <a:t>A</a:t>
-            </a:r>
-            <a:r>
-              <a:rPr kumimoji="1" lang="ja-JP" altLang="en-US"/>
-              <a:t>組</a:t>
-            </a:r>
-            <a:br>
-              <a:rPr lang="en-US" altLang="ja-JP" dirty="0"/>
-            </a:br>
-            <a:r>
-              <a:rPr lang="ja-JP" altLang="en-US"/>
-              <a:t>齋藤 遼</a:t>
-            </a:r>
             <a:endParaRPr kumimoji="1" lang="en-US" altLang="ja-JP" dirty="0"/>
           </a:p>
         </p:txBody>
@@ -24313,423 +24290,6 @@
           <p:cNvPr id="2" name="タイトル 1">
             <a:extLst>
               <a:ext uri="{FF2B5EF4-FFF2-40B4-BE49-F238E27FC236}">
-                <a16:creationId xmlns:a16="http://schemas.microsoft.com/office/drawing/2014/main" id="{F8CF34F9-70BC-5713-7B9B-BE0A36E3AAB8}"/>
-              </a:ext>
-            </a:extLst>
-          </p:cNvPr>
-          <p:cNvSpPr>
-            <a:spLocks noGrp="1"/>
-          </p:cNvSpPr>
-          <p:nvPr>
-            <p:ph type="title"/>
-          </p:nvPr>
-        </p:nvSpPr>
-        <p:spPr/>
-        <p:txBody>
-          <a:bodyPr/>
-          <a:lstStyle/>
-          <a:p>
-            <a:r>
-              <a:rPr kumimoji="1" lang="en-US" altLang="ja-JP" dirty="0"/>
-              <a:t>TSV</a:t>
-            </a:r>
-            <a:r>
-              <a:rPr kumimoji="1" lang="ja-JP" altLang="en-US"/>
-              <a:t>コードを構成するコード</a:t>
-            </a:r>
-          </a:p>
-        </p:txBody>
-      </p:sp>
-      <p:sp>
-        <p:nvSpPr>
-          <p:cNvPr id="3" name="テキスト プレースホルダー 2">
-            <a:extLst>
-              <a:ext uri="{FF2B5EF4-FFF2-40B4-BE49-F238E27FC236}">
-                <a16:creationId xmlns:a16="http://schemas.microsoft.com/office/drawing/2014/main" id="{1FD21210-82C7-AAB4-BAC8-21789404F836}"/>
-              </a:ext>
-            </a:extLst>
-          </p:cNvPr>
-          <p:cNvSpPr>
-            <a:spLocks noGrp="1"/>
-          </p:cNvSpPr>
-          <p:nvPr>
-            <p:ph type="body" idx="1"/>
-          </p:nvPr>
-        </p:nvSpPr>
-        <p:spPr/>
-        <p:txBody>
-          <a:bodyPr/>
-          <a:lstStyle/>
-          <a:p>
-            <a:endParaRPr kumimoji="1" lang="ja-JP" altLang="en-US"/>
-          </a:p>
-        </p:txBody>
-      </p:sp>
-      <p:graphicFrame>
-        <p:nvGraphicFramePr>
-          <p:cNvPr id="9" name="コンテンツ プレースホルダー 8">
-            <a:extLst>
-              <a:ext uri="{FF2B5EF4-FFF2-40B4-BE49-F238E27FC236}">
-                <a16:creationId xmlns:a16="http://schemas.microsoft.com/office/drawing/2014/main" id="{67D1D41E-139E-8FD1-221D-231FC7CD6682}"/>
-              </a:ext>
-            </a:extLst>
-          </p:cNvPr>
-          <p:cNvGraphicFramePr>
-            <a:graphicFrameLocks noGrp="1"/>
-          </p:cNvGraphicFramePr>
-          <p:nvPr>
-            <p:ph sz="half" idx="2"/>
-            <p:extLst>
-              <p:ext uri="{D42A27DB-BD31-4B8C-83A1-F6EECF244321}">
-                <p14:modId xmlns:p14="http://schemas.microsoft.com/office/powerpoint/2010/main" val="2121011175"/>
-              </p:ext>
-            </p:extLst>
-          </p:nvPr>
-        </p:nvGraphicFramePr>
-        <p:xfrm>
-          <a:off x="2589213" y="2549524"/>
-          <a:ext cx="4343400" cy="3350274"/>
-        </p:xfrm>
-        <a:graphic>
-          <a:graphicData uri="http://schemas.openxmlformats.org/drawingml/2006/table">
-            <a:tbl>
-              <a:tblPr firstRow="1" bandRow="1">
-                <a:tableStyleId>{5C22544A-7EE6-4342-B048-85BDC9FD1C3A}</a:tableStyleId>
-              </a:tblPr>
-              <a:tblGrid>
-                <a:gridCol w="1447800">
-                  <a:extLst>
-                    <a:ext uri="{9D8B030D-6E8A-4147-A177-3AD203B41FA5}">
-                      <a16:colId xmlns:a16="http://schemas.microsoft.com/office/drawing/2014/main" val="3371340692"/>
-                    </a:ext>
-                  </a:extLst>
-                </a:gridCol>
-                <a:gridCol w="1447800">
-                  <a:extLst>
-                    <a:ext uri="{9D8B030D-6E8A-4147-A177-3AD203B41FA5}">
-                      <a16:colId xmlns:a16="http://schemas.microsoft.com/office/drawing/2014/main" val="2769935659"/>
-                    </a:ext>
-                  </a:extLst>
-                </a:gridCol>
-                <a:gridCol w="1447800">
-                  <a:extLst>
-                    <a:ext uri="{9D8B030D-6E8A-4147-A177-3AD203B41FA5}">
-                      <a16:colId xmlns:a16="http://schemas.microsoft.com/office/drawing/2014/main" val="2436245548"/>
-                    </a:ext>
-                  </a:extLst>
-                </a:gridCol>
-              </a:tblGrid>
-              <a:tr h="558379">
-                <a:tc>
-                  <a:txBody>
-                    <a:bodyPr/>
-                    <a:lstStyle/>
-                    <a:p>
-                      <a:endParaRPr kumimoji="1" lang="ja-JP" altLang="en-US"/>
-                    </a:p>
-                  </a:txBody>
-                  <a:tcPr/>
-                </a:tc>
-                <a:tc>
-                  <a:txBody>
-                    <a:bodyPr/>
-                    <a:lstStyle/>
-                    <a:p>
-                      <a:endParaRPr kumimoji="1" lang="ja-JP" altLang="en-US"/>
-                    </a:p>
-                  </a:txBody>
-                  <a:tcPr/>
-                </a:tc>
-                <a:tc>
-                  <a:txBody>
-                    <a:bodyPr/>
-                    <a:lstStyle/>
-                    <a:p>
-                      <a:endParaRPr kumimoji="1" lang="ja-JP" altLang="en-US"/>
-                    </a:p>
-                  </a:txBody>
-                  <a:tcPr/>
-                </a:tc>
-                <a:extLst>
-                  <a:ext uri="{0D108BD9-81ED-4DB2-BD59-A6C34878D82A}">
-                    <a16:rowId xmlns:a16="http://schemas.microsoft.com/office/drawing/2014/main" val="3320288933"/>
-                  </a:ext>
-                </a:extLst>
-              </a:tr>
-              <a:tr h="558379">
-                <a:tc>
-                  <a:txBody>
-                    <a:bodyPr/>
-                    <a:lstStyle/>
-                    <a:p>
-                      <a:endParaRPr kumimoji="1" lang="ja-JP" altLang="en-US"/>
-                    </a:p>
-                  </a:txBody>
-                  <a:tcPr/>
-                </a:tc>
-                <a:tc>
-                  <a:txBody>
-                    <a:bodyPr/>
-                    <a:lstStyle/>
-                    <a:p>
-                      <a:endParaRPr kumimoji="1" lang="ja-JP" altLang="en-US"/>
-                    </a:p>
-                  </a:txBody>
-                  <a:tcPr/>
-                </a:tc>
-                <a:tc>
-                  <a:txBody>
-                    <a:bodyPr/>
-                    <a:lstStyle/>
-                    <a:p>
-                      <a:endParaRPr kumimoji="1" lang="ja-JP" altLang="en-US"/>
-                    </a:p>
-                  </a:txBody>
-                  <a:tcPr/>
-                </a:tc>
-                <a:extLst>
-                  <a:ext uri="{0D108BD9-81ED-4DB2-BD59-A6C34878D82A}">
-                    <a16:rowId xmlns:a16="http://schemas.microsoft.com/office/drawing/2014/main" val="74734561"/>
-                  </a:ext>
-                </a:extLst>
-              </a:tr>
-              <a:tr h="558379">
-                <a:tc>
-                  <a:txBody>
-                    <a:bodyPr/>
-                    <a:lstStyle/>
-                    <a:p>
-                      <a:endParaRPr kumimoji="1" lang="ja-JP" altLang="en-US"/>
-                    </a:p>
-                  </a:txBody>
-                  <a:tcPr/>
-                </a:tc>
-                <a:tc>
-                  <a:txBody>
-                    <a:bodyPr/>
-                    <a:lstStyle/>
-                    <a:p>
-                      <a:endParaRPr kumimoji="1" lang="ja-JP" altLang="en-US"/>
-                    </a:p>
-                  </a:txBody>
-                  <a:tcPr/>
-                </a:tc>
-                <a:tc>
-                  <a:txBody>
-                    <a:bodyPr/>
-                    <a:lstStyle/>
-                    <a:p>
-                      <a:endParaRPr kumimoji="1" lang="ja-JP" altLang="en-US"/>
-                    </a:p>
-                  </a:txBody>
-                  <a:tcPr/>
-                </a:tc>
-                <a:extLst>
-                  <a:ext uri="{0D108BD9-81ED-4DB2-BD59-A6C34878D82A}">
-                    <a16:rowId xmlns:a16="http://schemas.microsoft.com/office/drawing/2014/main" val="1361365019"/>
-                  </a:ext>
-                </a:extLst>
-              </a:tr>
-              <a:tr h="558379">
-                <a:tc>
-                  <a:txBody>
-                    <a:bodyPr/>
-                    <a:lstStyle/>
-                    <a:p>
-                      <a:endParaRPr kumimoji="1" lang="ja-JP" altLang="en-US"/>
-                    </a:p>
-                  </a:txBody>
-                  <a:tcPr/>
-                </a:tc>
-                <a:tc>
-                  <a:txBody>
-                    <a:bodyPr/>
-                    <a:lstStyle/>
-                    <a:p>
-                      <a:endParaRPr kumimoji="1" lang="ja-JP" altLang="en-US"/>
-                    </a:p>
-                  </a:txBody>
-                  <a:tcPr/>
-                </a:tc>
-                <a:tc>
-                  <a:txBody>
-                    <a:bodyPr/>
-                    <a:lstStyle/>
-                    <a:p>
-                      <a:endParaRPr kumimoji="1" lang="ja-JP" altLang="en-US"/>
-                    </a:p>
-                  </a:txBody>
-                  <a:tcPr/>
-                </a:tc>
-                <a:extLst>
-                  <a:ext uri="{0D108BD9-81ED-4DB2-BD59-A6C34878D82A}">
-                    <a16:rowId xmlns:a16="http://schemas.microsoft.com/office/drawing/2014/main" val="3453994252"/>
-                  </a:ext>
-                </a:extLst>
-              </a:tr>
-              <a:tr h="558379">
-                <a:tc>
-                  <a:txBody>
-                    <a:bodyPr/>
-                    <a:lstStyle/>
-                    <a:p>
-                      <a:endParaRPr kumimoji="1" lang="ja-JP" altLang="en-US"/>
-                    </a:p>
-                  </a:txBody>
-                  <a:tcPr/>
-                </a:tc>
-                <a:tc>
-                  <a:txBody>
-                    <a:bodyPr/>
-                    <a:lstStyle/>
-                    <a:p>
-                      <a:endParaRPr kumimoji="1" lang="ja-JP" altLang="en-US"/>
-                    </a:p>
-                  </a:txBody>
-                  <a:tcPr/>
-                </a:tc>
-                <a:tc>
-                  <a:txBody>
-                    <a:bodyPr/>
-                    <a:lstStyle/>
-                    <a:p>
-                      <a:endParaRPr kumimoji="1" lang="ja-JP" altLang="en-US"/>
-                    </a:p>
-                  </a:txBody>
-                  <a:tcPr/>
-                </a:tc>
-                <a:extLst>
-                  <a:ext uri="{0D108BD9-81ED-4DB2-BD59-A6C34878D82A}">
-                    <a16:rowId xmlns:a16="http://schemas.microsoft.com/office/drawing/2014/main" val="1086535151"/>
-                  </a:ext>
-                </a:extLst>
-              </a:tr>
-              <a:tr h="558379">
-                <a:tc>
-                  <a:txBody>
-                    <a:bodyPr/>
-                    <a:lstStyle/>
-                    <a:p>
-                      <a:endParaRPr kumimoji="1" lang="ja-JP" altLang="en-US"/>
-                    </a:p>
-                  </a:txBody>
-                  <a:tcPr/>
-                </a:tc>
-                <a:tc>
-                  <a:txBody>
-                    <a:bodyPr/>
-                    <a:lstStyle/>
-                    <a:p>
-                      <a:endParaRPr kumimoji="1" lang="ja-JP" altLang="en-US"/>
-                    </a:p>
-                  </a:txBody>
-                  <a:tcPr/>
-                </a:tc>
-                <a:tc>
-                  <a:txBody>
-                    <a:bodyPr/>
-                    <a:lstStyle/>
-                    <a:p>
-                      <a:endParaRPr kumimoji="1" lang="ja-JP" altLang="en-US"/>
-                    </a:p>
-                  </a:txBody>
-                  <a:tcPr/>
-                </a:tc>
-                <a:extLst>
-                  <a:ext uri="{0D108BD9-81ED-4DB2-BD59-A6C34878D82A}">
-                    <a16:rowId xmlns:a16="http://schemas.microsoft.com/office/drawing/2014/main" val="2552285451"/>
-                  </a:ext>
-                </a:extLst>
-              </a:tr>
-            </a:tbl>
-          </a:graphicData>
-        </a:graphic>
-      </p:graphicFrame>
-      <p:sp>
-        <p:nvSpPr>
-          <p:cNvPr id="5" name="テキスト プレースホルダー 4">
-            <a:extLst>
-              <a:ext uri="{FF2B5EF4-FFF2-40B4-BE49-F238E27FC236}">
-                <a16:creationId xmlns:a16="http://schemas.microsoft.com/office/drawing/2014/main" id="{48A35B9F-44A2-45FF-D32B-30C74D0DAC3A}"/>
-              </a:ext>
-            </a:extLst>
-          </p:cNvPr>
-          <p:cNvSpPr>
-            <a:spLocks noGrp="1"/>
-          </p:cNvSpPr>
-          <p:nvPr>
-            <p:ph type="body" sz="quarter" idx="3"/>
-          </p:nvPr>
-        </p:nvSpPr>
-        <p:spPr/>
-        <p:txBody>
-          <a:bodyPr/>
-          <a:lstStyle/>
-          <a:p>
-            <a:endParaRPr kumimoji="1" lang="ja-JP" altLang="en-US"/>
-          </a:p>
-        </p:txBody>
-      </p:sp>
-      <p:sp>
-        <p:nvSpPr>
-          <p:cNvPr id="6" name="コンテンツ プレースホルダー 5">
-            <a:extLst>
-              <a:ext uri="{FF2B5EF4-FFF2-40B4-BE49-F238E27FC236}">
-                <a16:creationId xmlns:a16="http://schemas.microsoft.com/office/drawing/2014/main" id="{81BAD32D-A571-05BE-DA32-8AF927DB02A8}"/>
-              </a:ext>
-            </a:extLst>
-          </p:cNvPr>
-          <p:cNvSpPr>
-            <a:spLocks noGrp="1"/>
-          </p:cNvSpPr>
-          <p:nvPr>
-            <p:ph sz="quarter" idx="4"/>
-          </p:nvPr>
-        </p:nvSpPr>
-        <p:spPr/>
-        <p:txBody>
-          <a:bodyPr/>
-          <a:lstStyle/>
-          <a:p>
-            <a:endParaRPr kumimoji="1" lang="ja-JP" altLang="en-US"/>
-          </a:p>
-        </p:txBody>
-      </p:sp>
-    </p:spTree>
-    <p:extLst>
-      <p:ext uri="{BB962C8B-B14F-4D97-AF65-F5344CB8AC3E}">
-        <p14:creationId xmlns:p14="http://schemas.microsoft.com/office/powerpoint/2010/main" val="1815914304"/>
-      </p:ext>
-    </p:extLst>
-  </p:cSld>
-  <p:clrMapOvr>
-    <a:masterClrMapping/>
-  </p:clrMapOvr>
-</p:sld>
-</file>
-
-<file path=ppt/slides/slide7.xml><?xml version="1.0" encoding="utf-8"?>
-<p:sld xmlns:a="http://schemas.openxmlformats.org/drawingml/2006/main" xmlns:r="http://schemas.openxmlformats.org/officeDocument/2006/relationships" xmlns:p="http://schemas.openxmlformats.org/presentationml/2006/main">
-  <p:cSld>
-    <p:spTree>
-      <p:nvGrpSpPr>
-        <p:cNvPr id="1" name=""/>
-        <p:cNvGrpSpPr/>
-        <p:nvPr/>
-      </p:nvGrpSpPr>
-      <p:grpSpPr>
-        <a:xfrm>
-          <a:off x="0" y="0"/>
-          <a:ext cx="0" cy="0"/>
-          <a:chOff x="0" y="0"/>
-          <a:chExt cx="0" cy="0"/>
-        </a:xfrm>
-      </p:grpSpPr>
-      <p:sp>
-        <p:nvSpPr>
-          <p:cNvPr id="2" name="タイトル 1">
-            <a:extLst>
-              <a:ext uri="{FF2B5EF4-FFF2-40B4-BE49-F238E27FC236}">
                 <a16:creationId xmlns:a16="http://schemas.microsoft.com/office/drawing/2014/main" id="{E5D84F83-50DF-C9A1-8D70-AB689B21AA9F}"/>
               </a:ext>
             </a:extLst>
@@ -24775,38 +24335,7 @@
           <a:bodyPr/>
           <a:lstStyle/>
           <a:p>
-            <a:r>
-              <a:rPr lang="en-US" altLang="ja-JP" dirty="0"/>
-              <a:t>Object TSV Code</a:t>
-            </a:r>
-          </a:p>
-          <a:p>
-            <a:r>
-              <a:rPr lang="en-US" altLang="ja-JP" dirty="0"/>
-              <a:t>Object Name</a:t>
-            </a:r>
-          </a:p>
-          <a:p>
-            <a:r>
-              <a:rPr lang="en-US" altLang="ja-JP" dirty="0"/>
-              <a:t>Object Phonetic Name</a:t>
-            </a:r>
-          </a:p>
-          <a:p>
-            <a:r>
-              <a:rPr lang="en-US" altLang="ja-JP" dirty="0"/>
-              <a:t>Parent Object TSV Code</a:t>
-            </a:r>
-          </a:p>
-          <a:p>
-            <a:r>
-              <a:rPr kumimoji="1" lang="en-US" altLang="ja-JP" dirty="0"/>
-              <a:t>Shelf TSV Code</a:t>
-            </a:r>
-            <a:r>
-              <a:rPr kumimoji="1" lang="ja-JP" altLang="en-US"/>
-              <a:t>（書架オブジェクトを除く）</a:t>
-            </a:r>
+            <a:endParaRPr kumimoji="1" lang="ja-JP" altLang="en-US"/>
           </a:p>
         </p:txBody>
       </p:sp>

</xml_diff>